<commit_message>
Update KPI slide 2 with portal data and three dynamic APIs
Document field-person KPI portal entries (division/district/tehsil)
and PLRA APIs for Inheritance Mutation, Partition Proceeding, and
Attestation of Registries.

Co-authored-by: Gulraiz Ahmed <GulraizAhmed@users.noreply.github.com>
</commit_message>
<xml_diff>
--- a/PLRA_KPI_Project_Presentation.pptx
+++ b/PLRA_KPI_Project_Presentation.pptx
@@ -3899,7 +3899,7 @@
                 </a:solidFill>
                 <a:latin typeface="Calibri"/>
               </a:rPr>
-              <a:t>Reference data received statically vs. operational data received dynamically</a:t>
+              <a:t>Portal / database entries vs. PLRA-developed API feeds</a:t>
             </a:r>
           </a:p>
         </p:txBody>
@@ -4131,7 +4131,7 @@
         <p:spPr>
           <a:xfrm>
             <a:off x="777240" y="2103120"/>
-            <a:ext cx="4800600" cy="365760"/>
+            <a:ext cx="4800600" cy="411480"/>
           </a:xfrm>
           <a:prstGeom prst="rect">
             <a:avLst/>
@@ -4159,7 +4159,7 @@
                 </a:solidFill>
                 <a:latin typeface="Calibri"/>
               </a:rPr>
-              <a:t>One-time / reference datasets received for setup</a:t>
+              <a:t>Entered by field officers via the KPI portal</a:t>
             </a:r>
           </a:p>
         </p:txBody>
@@ -4172,8 +4172,8 @@
         </p:nvSpPr>
         <p:spPr>
           <a:xfrm>
-            <a:off x="777240" y="2560320"/>
-            <a:ext cx="4800600" cy="3108960"/>
+            <a:off x="777240" y="2606040"/>
+            <a:ext cx="4800600" cy="3154680"/>
           </a:xfrm>
           <a:prstGeom prst="rect">
             <a:avLst/>
@@ -4201,7 +4201,7 @@
                 </a:solidFill>
                 <a:latin typeface="Calibri"/>
               </a:rPr>
-              <a:t>•  District &amp; tehsil master lists</a:t>
+              <a:t>•  Data submitted by field persons (DC, ADCR, AC, and other ranks)</a:t>
             </a:r>
           </a:p>
           <a:p>
@@ -4220,7 +4220,7 @@
                 </a:solidFill>
                 <a:latin typeface="Calibri"/>
               </a:rPr>
-              <a:t>•  Rank / designation hierarchy of authorities</a:t>
+              <a:t>•  Captured through the KPI portal and stored in the database</a:t>
             </a:r>
           </a:p>
           <a:p>
@@ -4239,64 +4239,7 @@
                 </a:solidFill>
                 <a:latin typeface="Calibri"/>
               </a:rPr>
-              <a:t>•  Officer-to-territory organizational mapping</a:t>
-            </a:r>
-          </a:p>
-          <a:p>
-            <a:pPr algn="l">
-              <a:spcBef>
-                <a:spcPts val="0"/>
-              </a:spcBef>
-              <a:spcAft>
-                <a:spcPts val="400"/>
-              </a:spcAft>
-            </a:pPr>
-            <a:r>
-              <a:rPr sz="1300" b="0" i="0">
-                <a:solidFill>
-                  <a:srgbClr val="222222"/>
-                </a:solidFill>
-                <a:latin typeface="Calibri"/>
-              </a:rPr>
-              <a:t>•  KPI indicator definitions &amp; weightages</a:t>
-            </a:r>
-          </a:p>
-          <a:p>
-            <a:pPr algn="l">
-              <a:spcBef>
-                <a:spcPts val="0"/>
-              </a:spcBef>
-              <a:spcAft>
-                <a:spcPts val="400"/>
-              </a:spcAft>
-            </a:pPr>
-            <a:r>
-              <a:rPr sz="1300" b="0" i="0">
-                <a:solidFill>
-                  <a:srgbClr val="222222"/>
-                </a:solidFill>
-                <a:latin typeface="Calibri"/>
-              </a:rPr>
-              <a:t>•  Target / benchmark thresholds per rank</a:t>
-            </a:r>
-          </a:p>
-          <a:p>
-            <a:pPr algn="l">
-              <a:spcBef>
-                <a:spcPts val="0"/>
-              </a:spcBef>
-              <a:spcAft>
-                <a:spcPts val="400"/>
-              </a:spcAft>
-            </a:pPr>
-            <a:r>
-              <a:rPr sz="1300" b="0" i="0">
-                <a:solidFill>
-                  <a:srgbClr val="222222"/>
-                </a:solidFill>
-                <a:latin typeface="Calibri"/>
-              </a:rPr>
-              <a:t>•  Scoring &amp; ranking formula configuration</a:t>
+              <a:t>•  Maintained and reported Division-wise, District-wise, and Tehsil-wise</a:t>
             </a:r>
           </a:p>
         </p:txBody>
@@ -4442,7 +4385,7 @@
         <p:spPr>
           <a:xfrm>
             <a:off x="6583680" y="2103120"/>
-            <a:ext cx="4800600" cy="365760"/>
+            <a:ext cx="4800600" cy="411480"/>
           </a:xfrm>
           <a:prstGeom prst="rect">
             <a:avLst/>
@@ -4470,7 +4413,7 @@
                 </a:solidFill>
                 <a:latin typeface="Calibri"/>
               </a:rPr>
-              <a:t>Ongoing / live feeds for performance measurement</a:t>
+              <a:t>Received through 3 APIs developed by the PLRA team</a:t>
             </a:r>
           </a:p>
         </p:txBody>
@@ -4483,8 +4426,8 @@
         </p:nvSpPr>
         <p:spPr>
           <a:xfrm>
-            <a:off x="6583680" y="2560320"/>
-            <a:ext cx="4800600" cy="3108960"/>
+            <a:off x="6583680" y="2606040"/>
+            <a:ext cx="4800600" cy="3154680"/>
           </a:xfrm>
           <a:prstGeom prst="rect">
             <a:avLst/>
@@ -4506,13 +4449,13 @@
               </a:spcAft>
             </a:pPr>
             <a:r>
-              <a:rPr sz="1300" b="0" i="0">
-                <a:solidFill>
-                  <a:srgbClr val="222222"/>
+              <a:rPr sz="1200" b="0" i="0">
+                <a:solidFill>
+                  <a:srgbClr val="4A4A4A"/>
                 </a:solidFill>
                 <a:latin typeface="Calibri"/>
               </a:rPr>
-              <a:t>•  Service delivery volumes (district-wise)</a:t>
+              <a:t>The PLRA team has developed three APIs to receive data dynamically:</a:t>
             </a:r>
           </a:p>
           <a:p>
@@ -4525,13 +4468,13 @@
               </a:spcAft>
             </a:pPr>
             <a:r>
-              <a:rPr sz="1300" b="0" i="0">
-                <a:solidFill>
-                  <a:srgbClr val="222222"/>
+              <a:rPr sz="800" b="0" i="0">
+                <a:solidFill>
+                  <a:srgbClr val="FFFFFF"/>
                 </a:solidFill>
                 <a:latin typeface="Calibri"/>
               </a:rPr>
-              <a:t>•  Processing &amp; turnaround time metrics</a:t>
+              <a:t/>
             </a:r>
           </a:p>
           <a:p>
@@ -4550,7 +4493,7 @@
                 </a:solidFill>
                 <a:latin typeface="Calibri"/>
               </a:rPr>
-              <a:t>•  Pendency and escalation statistics</a:t>
+              <a:t>•  Inheritance Mutation</a:t>
             </a:r>
           </a:p>
           <a:p>
@@ -4569,7 +4512,7 @@
                 </a:solidFill>
                 <a:latin typeface="Calibri"/>
               </a:rPr>
-              <a:t>•  Complaint / grievance resolution indicators</a:t>
+              <a:t>•  Partition Proceeding</a:t>
             </a:r>
           </a:p>
           <a:p>
@@ -4588,26 +4531,7 @@
                 </a:solidFill>
                 <a:latin typeface="Calibri"/>
               </a:rPr>
-              <a:t>•  Period-wise performance score calculations</a:t>
-            </a:r>
-          </a:p>
-          <a:p>
-            <a:pPr algn="l">
-              <a:spcBef>
-                <a:spcPts val="0"/>
-              </a:spcBef>
-              <a:spcAft>
-                <a:spcPts val="400"/>
-              </a:spcAft>
-            </a:pPr>
-            <a:r>
-              <a:rPr sz="1300" b="0" i="0">
-                <a:solidFill>
-                  <a:srgbClr val="222222"/>
-                </a:solidFill>
-                <a:latin typeface="Calibri"/>
-              </a:rPr>
-              <a:t>•  Live district-wise authority rankings</a:t>
+              <a:t>•  Attestation of Registries</a:t>
             </a:r>
           </a:p>
         </p:txBody>

</xml_diff>

<commit_message>
Clarify KPI slide 3 next steps after vendor documents
Note module-wise man-hour project plan requirement and that
system work starts after document receipt via dynamic API approach.

Co-authored-by: Gulraiz Ahmed <GulraizAhmed@users.noreply.github.com>
</commit_message>
<xml_diff>
--- a/PLRA_KPI_Project_Presentation.pptx
+++ b/PLRA_KPI_Project_Presentation.pptx
@@ -5006,8 +5006,8 @@
         </p:nvSpPr>
         <p:spPr>
           <a:xfrm>
-            <a:off x="502920" y="1600200"/>
-            <a:ext cx="11155680" cy="1234440"/>
+            <a:off x="502920" y="1554480"/>
+            <a:ext cx="11155680" cy="1051560"/>
           </a:xfrm>
           <a:prstGeom prst="roundRect">
             <a:avLst>
@@ -5053,8 +5053,8 @@
         </p:nvSpPr>
         <p:spPr>
           <a:xfrm>
-            <a:off x="502920" y="1600200"/>
-            <a:ext cx="109728" cy="1234440"/>
+            <a:off x="502920" y="1554480"/>
+            <a:ext cx="109728" cy="1051560"/>
           </a:xfrm>
           <a:prstGeom prst="rect">
             <a:avLst/>
@@ -5096,7 +5096,7 @@
         </p:nvSpPr>
         <p:spPr>
           <a:xfrm>
-            <a:off x="822960" y="1874519"/>
+            <a:off x="822960" y="1783080"/>
             <a:ext cx="1463040" cy="411480"/>
           </a:xfrm>
           <a:prstGeom prst="roundRect">
@@ -5157,8 +5157,8 @@
         </p:nvSpPr>
         <p:spPr>
           <a:xfrm>
-            <a:off x="2468880" y="1783080"/>
-            <a:ext cx="8686800" cy="365760"/>
+            <a:off x="2468880" y="1691640"/>
+            <a:ext cx="8686800" cy="320040"/>
           </a:xfrm>
           <a:prstGeom prst="rect">
             <a:avLst/>
@@ -5199,8 +5199,8 @@
         </p:nvSpPr>
         <p:spPr>
           <a:xfrm>
-            <a:off x="2468880" y="2194560"/>
-            <a:ext cx="8686800" cy="411480"/>
+            <a:off x="2468880" y="2057400"/>
+            <a:ext cx="8686800" cy="365760"/>
           </a:xfrm>
           <a:prstGeom prst="rect">
             <a:avLst/>
@@ -5241,8 +5241,8 @@
         </p:nvSpPr>
         <p:spPr>
           <a:xfrm>
-            <a:off x="502920" y="3063240"/>
-            <a:ext cx="11155680" cy="3063240"/>
+            <a:off x="502920" y="2788920"/>
+            <a:ext cx="11155680" cy="3383280"/>
           </a:xfrm>
           <a:prstGeom prst="roundRect">
             <a:avLst>
@@ -5288,8 +5288,8 @@
         </p:nvSpPr>
         <p:spPr>
           <a:xfrm>
-            <a:off x="502920" y="3063240"/>
-            <a:ext cx="91440" cy="3063240"/>
+            <a:off x="502920" y="2788920"/>
+            <a:ext cx="91440" cy="3383280"/>
           </a:xfrm>
           <a:prstGeom prst="rect">
             <a:avLst/>
@@ -5331,7 +5331,7 @@
         </p:nvSpPr>
         <p:spPr>
           <a:xfrm>
-            <a:off x="777240" y="3246120"/>
+            <a:off x="777240" y="2971800"/>
             <a:ext cx="10698480" cy="365760"/>
           </a:xfrm>
           <a:prstGeom prst="rect">
@@ -5373,8 +5373,8 @@
         </p:nvSpPr>
         <p:spPr>
           <a:xfrm>
-            <a:off x="777240" y="3703320"/>
-            <a:ext cx="10698480" cy="2240280"/>
+            <a:off x="777240" y="3429000"/>
+            <a:ext cx="10698480" cy="2560320"/>
           </a:xfrm>
           <a:prstGeom prst="rect">
             <a:avLst/>
@@ -5396,7 +5396,7 @@
               </a:spcAft>
             </a:pPr>
             <a:r>
-              <a:rPr sz="1300" b="0" i="0">
+              <a:rPr sz="1200" b="0" i="0">
                 <a:solidFill>
                   <a:srgbClr val="4A4A4A"/>
                 </a:solidFill>
@@ -5415,7 +5415,7 @@
               </a:spcAft>
             </a:pPr>
             <a:r>
-              <a:rPr sz="600" b="0" i="0">
+              <a:rPr sz="400" b="0" i="0">
                 <a:solidFill>
                   <a:srgbClr val="FFFFFF"/>
                 </a:solidFill>
@@ -5434,7 +5434,7 @@
               </a:spcAft>
             </a:pPr>
             <a:r>
-              <a:rPr sz="1400" b="0" i="0">
+              <a:rPr sz="1300" b="0" i="0">
                 <a:solidFill>
                   <a:srgbClr val="222222"/>
                 </a:solidFill>
@@ -5453,7 +5453,7 @@
               </a:spcAft>
             </a:pPr>
             <a:r>
-              <a:rPr sz="1400" b="0" i="0">
+              <a:rPr sz="1300" b="0" i="0">
                 <a:solidFill>
                   <a:srgbClr val="222222"/>
                 </a:solidFill>
@@ -5472,7 +5472,7 @@
               </a:spcAft>
             </a:pPr>
             <a:r>
-              <a:rPr sz="1400" b="0" i="0">
+              <a:rPr sz="1300" b="0" i="0">
                 <a:solidFill>
                   <a:srgbClr val="222222"/>
                 </a:solidFill>
@@ -5491,7 +5491,7 @@
               </a:spcAft>
             </a:pPr>
             <a:r>
-              <a:rPr sz="1400" b="0" i="0">
+              <a:rPr sz="1300" b="0" i="0">
                 <a:solidFill>
                   <a:srgbClr val="222222"/>
                 </a:solidFill>
@@ -5510,13 +5510,70 @@
               </a:spcAft>
             </a:pPr>
             <a:r>
-              <a:rPr sz="1400" b="0" i="0">
+              <a:rPr sz="1300" b="0" i="0">
                 <a:solidFill>
                   <a:srgbClr val="222222"/>
                 </a:solidFill>
                 <a:latin typeface="Calibri"/>
               </a:rPr>
-              <a:t>•  Project Plan  — Timeline, milestones &amp; delivery schedule</a:t>
+              <a:t>•  Project Plan  — with clear module-wise man-hour estimates</a:t>
+            </a:r>
+          </a:p>
+          <a:p>
+            <a:pPr algn="l">
+              <a:spcBef>
+                <a:spcPts val="0"/>
+              </a:spcBef>
+              <a:spcAft>
+                <a:spcPts val="400"/>
+              </a:spcAft>
+            </a:pPr>
+            <a:r>
+              <a:rPr sz="600" b="0" i="0">
+                <a:solidFill>
+                  <a:srgbClr val="FFFFFF"/>
+                </a:solidFill>
+                <a:latin typeface="Calibri"/>
+              </a:rPr>
+              <a:t/>
+            </a:r>
+          </a:p>
+          <a:p>
+            <a:pPr algn="l">
+              <a:spcBef>
+                <a:spcPts val="0"/>
+              </a:spcBef>
+              <a:spcAft>
+                <a:spcPts val="400"/>
+              </a:spcAft>
+            </a:pPr>
+            <a:r>
+              <a:rPr sz="1200" b="0" i="0">
+                <a:solidFill>
+                  <a:srgbClr val="4A4A4A"/>
+                </a:solidFill>
+                <a:latin typeface="Calibri"/>
+              </a:rPr>
+              <a:t>Once the complete project plan and documents are received, work on the system will commence,</a:t>
+            </a:r>
+          </a:p>
+          <a:p>
+            <a:pPr algn="l">
+              <a:spcBef>
+                <a:spcPts val="0"/>
+              </a:spcBef>
+              <a:spcAft>
+                <a:spcPts val="400"/>
+              </a:spcAft>
+            </a:pPr>
+            <a:r>
+              <a:rPr sz="1200" b="0" i="0">
+                <a:solidFill>
+                  <a:srgbClr val="4A4A4A"/>
+                </a:solidFill>
+                <a:latin typeface="Calibri"/>
+              </a:rPr>
+              <a:t>following a dynamic approach by obtaining data through the developed APIs.</a:t>
             </a:r>
           </a:p>
         </p:txBody>

</xml_diff>

<commit_message>
Add attached-department files and dynamic API integration target
Slide 2 notes Excel/PDF data from attached departments; slide 3
states the goal to develop, integrate, and store API data in the DB.

Co-authored-by: Gulraiz Ahmed <GulraizAhmed@users.noreply.github.com>
</commit_message>
<xml_diff>
--- a/PLRA_KPI_Project_Presentation.pptx
+++ b/PLRA_KPI_Project_Presentation.pptx
@@ -4159,7 +4159,7 @@
                 </a:solidFill>
                 <a:latin typeface="Calibri"/>
               </a:rPr>
-              <a:t>Entered by field officers via the KPI portal</a:t>
+              <a:t>Portal entries and attached department files</a:t>
             </a:r>
           </a:p>
         </p:txBody>
@@ -4240,6 +4240,25 @@
                 <a:latin typeface="Calibri"/>
               </a:rPr>
               <a:t>•  Maintained and reported Division-wise, District-wise, and Tehsil-wise</a:t>
+            </a:r>
+          </a:p>
+          <a:p>
+            <a:pPr algn="l">
+              <a:spcBef>
+                <a:spcPts val="0"/>
+              </a:spcBef>
+              <a:spcAft>
+                <a:spcPts val="400"/>
+              </a:spcAft>
+            </a:pPr>
+            <a:r>
+              <a:rPr sz="1300" b="0" i="0">
+                <a:solidFill>
+                  <a:srgbClr val="222222"/>
+                </a:solidFill>
+                <a:latin typeface="Calibri"/>
+              </a:rPr>
+              <a:t>•  Attached departments data received in Excel and PDF form</a:t>
             </a:r>
           </a:p>
         </p:txBody>
@@ -5554,7 +5573,7 @@
                 </a:solidFill>
                 <a:latin typeface="Calibri"/>
               </a:rPr>
-              <a:t>Once the complete project plan and documents are received, work on the system will commence,</a:t>
+              <a:t>Once the complete project plan and documents are received, work on the system will commence.</a:t>
             </a:r>
           </a:p>
           <a:p>
@@ -5567,13 +5586,51 @@
               </a:spcAft>
             </a:pPr>
             <a:r>
-              <a:rPr sz="1200" b="0" i="0">
-                <a:solidFill>
-                  <a:srgbClr val="4A4A4A"/>
+              <a:rPr sz="400" b="0" i="0">
+                <a:solidFill>
+                  <a:srgbClr val="FFFFFF"/>
                 </a:solidFill>
                 <a:latin typeface="Calibri"/>
               </a:rPr>
-              <a:t>following a dynamic approach by obtaining data through the developed APIs.</a:t>
+              <a:t/>
+            </a:r>
+          </a:p>
+          <a:p>
+            <a:pPr algn="l">
+              <a:spcBef>
+                <a:spcPts val="0"/>
+              </a:spcBef>
+              <a:spcAft>
+                <a:spcPts val="400"/>
+              </a:spcAft>
+            </a:pPr>
+            <a:r>
+              <a:rPr sz="1200" b="1" i="0">
+                <a:solidFill>
+                  <a:srgbClr val="0B4F2C"/>
+                </a:solidFill>
+                <a:latin typeface="Calibri"/>
+              </a:rPr>
+              <a:t>Dynamic Data Target: Develop the APIs, integrate them with our system to receive data</a:t>
+            </a:r>
+          </a:p>
+          <a:p>
+            <a:pPr algn="l">
+              <a:spcBef>
+                <a:spcPts val="0"/>
+              </a:spcBef>
+              <a:spcAft>
+                <a:spcPts val="400"/>
+              </a:spcAft>
+            </a:pPr>
+            <a:r>
+              <a:rPr sz="1200" b="1" i="0">
+                <a:solidFill>
+                  <a:srgbClr val="0B4F2C"/>
+                </a:solidFill>
+                <a:latin typeface="Calibri"/>
+              </a:rPr>
+              <a:t>dynamically, and store the received data in the database.</a:t>
             </a:r>
           </a:p>
         </p:txBody>

</xml_diff>